<commit_message>
Update feedback data with latest Parent Feedback Forms - 60,255 total responses
</commit_message>
<xml_diff>
--- a/Pre_Primary_Feedback_Analysis.pptx
+++ b/Pre_Primary_Feedback_Analysis.pptx
@@ -180,22 +180,22 @@
                 <c:formatCode>General</c:formatCode>
                 <c:ptCount val="6"/>
                 <c:pt idx="0">
-                  <c:v>4.323367263940507</c:v>
+                  <c:v>4.31529486798909</c:v>
                 </c:pt>
                 <c:pt idx="1">
-                  <c:v>4.33689124013398</c:v>
+                  <c:v>4.321796281853874</c:v>
                 </c:pt>
                 <c:pt idx="2">
-                  <c:v>4.425840422814704</c:v>
+                  <c:v>4.4761481715462725</c:v>
                 </c:pt>
                 <c:pt idx="3">
-                  <c:v>3.9971569086955956</c:v>
+                  <c:v>3.9477280077619663</c:v>
                 </c:pt>
                 <c:pt idx="4">
-                  <c:v>4.429226823445013</c:v>
+                  <c:v>4.4203998014877</c:v>
                 </c:pt>
                 <c:pt idx="5">
-                  <c:v>3.8842192797287787</c:v>
+                  <c:v>3.882804674457429</c:v>
                 </c:pt>
               </c:numCache>
             </c:numRef>
@@ -306,13 +306,13 @@
                 <c:formatCode>General</c:formatCode>
                 <c:ptCount val="3"/>
                 <c:pt idx="0">
-                  <c:v>4.469808754430797</c:v>
+                  <c:v>4.461181715230716</c:v>
                 </c:pt>
                 <c:pt idx="1">
-                  <c:v>4.477313786157776</c:v>
+                  <c:v>4.46882698159687</c:v>
                 </c:pt>
                 <c:pt idx="2">
-                  <c:v>4.3062012286236095</c:v>
+                  <c:v>4.2959329710144925</c:v>
                 </c:pt>
               </c:numCache>
             </c:numRef>
@@ -435,25 +435,25 @@
                 <c:formatCode>General</c:formatCode>
                 <c:ptCount val="7"/>
                 <c:pt idx="0">
-                  <c:v>4.407635723166183</c:v>
+                  <c:v>4.398062083479481</c:v>
                 </c:pt>
                 <c:pt idx="1">
-                  <c:v>4.425470711297071</c:v>
+                  <c:v>4.416042875492758</c:v>
                 </c:pt>
                 <c:pt idx="2">
-                  <c:v>4.462504663599055</c:v>
+                  <c:v>4.430287883885231</c:v>
                 </c:pt>
                 <c:pt idx="3">
-                  <c:v>4.36720052177694</c:v>
+                  <c:v>4.387235810354676</c:v>
                 </c:pt>
                 <c:pt idx="4">
-                  <c:v>4.4356188704768345</c:v>
+                  <c:v>4.397199981270778</c:v>
                 </c:pt>
                 <c:pt idx="5">
-                  <c:v>4.307357669756005</c:v>
+                  <c:v>4.307190443372387</c:v>
                 </c:pt>
                 <c:pt idx="6">
-                  <c:v>4.136848163347012</c:v>
+                  <c:v>4.099907717713342</c:v>
                 </c:pt>
               </c:numCache>
             </c:numRef>
@@ -560,10 +560,10 @@
                 <c:formatCode>General</c:formatCode>
                 <c:ptCount val="4"/>
                 <c:pt idx="0">
-                  <c:v>31966</c:v>
+                  <c:v>36563</c:v>
                 </c:pt>
                 <c:pt idx="1">
-                  <c:v>19178</c:v>
+                  <c:v>22048</c:v>
                 </c:pt>
                 <c:pt idx="2">
                   <c:v>0</c:v>
@@ -630,10 +630,10 @@
               <c:strCache>
                 <c:ptCount val="4"/>
                 <c:pt idx="0">
+                  <c:v>The safety measures imple</c:v>
+                </c:pt>
+                <c:pt idx="1">
                   <c:v>The school offers adequat</c:v>
-                </c:pt>
-                <c:pt idx="1">
-                  <c:v>The safety measures imple</c:v>
                 </c:pt>
                 <c:pt idx="2">
                   <c:v>Campus hygiene and genera</c:v>
@@ -651,16 +651,16 @@
                 <c:formatCode>General</c:formatCode>
                 <c:ptCount val="4"/>
                 <c:pt idx="0">
-                  <c:v>4.177346698591778</c:v>
+                  <c:v>4.240696443276734</c:v>
                 </c:pt>
                 <c:pt idx="1">
-                  <c:v>4.133281127642913</c:v>
+                  <c:v>4.190962656871748</c:v>
                 </c:pt>
                 <c:pt idx="2">
-                  <c:v>3.9723413198823034</c:v>
+                  <c:v>3.7637713771377137</c:v>
                 </c:pt>
                 <c:pt idx="3">
-                  <c:v>3.5242068684441965</c:v>
+                  <c:v>3.3694854627166837</c:v>
                 </c:pt>
               </c:numCache>
             </c:numRef>
@@ -767,13 +767,13 @@
                 <c:formatCode>General</c:formatCode>
                 <c:ptCount val="4"/>
                 <c:pt idx="0">
-                  <c:v>37681</c:v>
+                  <c:v>42876</c:v>
                 </c:pt>
                 <c:pt idx="1">
-                  <c:v>2510</c:v>
+                  <c:v>2994</c:v>
                 </c:pt>
                 <c:pt idx="2">
-                  <c:v>11113</c:v>
+                  <c:v>5609</c:v>
                 </c:pt>
                 <c:pt idx="3">
                   <c:v>0</c:v>
@@ -843,28 +843,28 @@
                   <c:v>Coimbatore 4</c:v>
                 </c:pt>
                 <c:pt idx="2">
+                  <c:v>Coimbatore Chetty Street</c:v>
+                </c:pt>
+                <c:pt idx="3">
                   <c:v>Hosur 3</c:v>
                 </c:pt>
-                <c:pt idx="3">
-                  <c:v>Coimbatore Chetty Street</c:v>
-                </c:pt>
                 <c:pt idx="4">
+                  <c:v>Valasaravakkam</c:v>
+                </c:pt>
+                <c:pt idx="5">
                   <c:v>Vellore</c:v>
                 </c:pt>
-                <c:pt idx="5">
-                  <c:v>Valasaravakkam</c:v>
-                </c:pt>
                 <c:pt idx="6">
+                  <c:v>Madurai</c:v>
+                </c:pt>
+                <c:pt idx="7">
+                  <c:v>Tiruppur 2</c:v>
+                </c:pt>
+                <c:pt idx="8">
+                  <c:v>Salem Yercaud Foothills</c:v>
+                </c:pt>
+                <c:pt idx="9">
                   <c:v>Thanjavur</c:v>
-                </c:pt>
-                <c:pt idx="7">
-                  <c:v>Madurai</c:v>
-                </c:pt>
-                <c:pt idx="8">
-                  <c:v>Tiruppur 2</c:v>
-                </c:pt>
-                <c:pt idx="9">
-                  <c:v>Coimbatore 6</c:v>
                 </c:pt>
               </c:strCache>
             </c:strRef>
@@ -876,34 +876,34 @@
                 <c:formatCode>General</c:formatCode>
                 <c:ptCount val="10"/>
                 <c:pt idx="0">
-                  <c:v>4.592698114545079</c:v>
+                  <c:v>4.5788796890073105</c:v>
                 </c:pt>
                 <c:pt idx="1">
-                  <c:v>4.567689404358762</c:v>
+                  <c:v>4.566749988643354</c:v>
                 </c:pt>
                 <c:pt idx="2">
-                  <c:v>4.548308238094193</c:v>
+                  <c:v>4.5445643107574805</c:v>
                 </c:pt>
                 <c:pt idx="3">
-                  <c:v>4.546401322495105</c:v>
+                  <c:v>4.537865580963501</c:v>
                 </c:pt>
                 <c:pt idx="4">
-                  <c:v>4.5186960192690995</c:v>
+                  <c:v>4.521570170405109</c:v>
                 </c:pt>
                 <c:pt idx="5">
-                  <c:v>4.474387468442645</c:v>
+                  <c:v>4.513047560193372</c:v>
                 </c:pt>
                 <c:pt idx="6">
-                  <c:v>4.4234903920678015</c:v>
+                  <c:v>4.447416939450967</c:v>
                 </c:pt>
                 <c:pt idx="7">
-                  <c:v>4.423208073580054</c:v>
+                  <c:v>4.4176247888023905</c:v>
                 </c:pt>
                 <c:pt idx="8">
-                  <c:v>4.418338378937039</c:v>
+                  <c:v>4.415833521022825</c:v>
                 </c:pt>
                 <c:pt idx="9">
-                  <c:v>4.413732039431787</c:v>
+                  <c:v>4.414621038220025</c:v>
                 </c:pt>
               </c:numCache>
             </c:numRef>
@@ -1002,28 +1002,28 @@
                   <c:v>Coimbatore 4</c:v>
                 </c:pt>
                 <c:pt idx="2">
+                  <c:v>Coimbatore Chetty Street</c:v>
+                </c:pt>
+                <c:pt idx="3">
                   <c:v>Hosur 3</c:v>
                 </c:pt>
-                <c:pt idx="3">
-                  <c:v>Coimbatore Chetty Street</c:v>
-                </c:pt>
                 <c:pt idx="4">
+                  <c:v>Valasaravakkam</c:v>
+                </c:pt>
+                <c:pt idx="5">
                   <c:v>Vellore</c:v>
                 </c:pt>
-                <c:pt idx="5">
-                  <c:v>Valasaravakkam</c:v>
-                </c:pt>
                 <c:pt idx="6">
+                  <c:v>Madurai</c:v>
+                </c:pt>
+                <c:pt idx="7">
+                  <c:v>Tiruppur 2</c:v>
+                </c:pt>
+                <c:pt idx="8">
+                  <c:v>Salem Yercaud Foothills</c:v>
+                </c:pt>
+                <c:pt idx="9">
                   <c:v>Thanjavur</c:v>
-                </c:pt>
-                <c:pt idx="7">
-                  <c:v>Madurai</c:v>
-                </c:pt>
-                <c:pt idx="8">
-                  <c:v>Tiruppur 2</c:v>
-                </c:pt>
-                <c:pt idx="9">
-                  <c:v>Coimbatore 6</c:v>
                 </c:pt>
               </c:strCache>
             </c:strRef>
@@ -1035,34 +1035,34 @@
                 <c:formatCode>General</c:formatCode>
                 <c:ptCount val="10"/>
                 <c:pt idx="0">
-                  <c:v>4.592698114545079</c:v>
+                  <c:v>4.5788796890073105</c:v>
                 </c:pt>
                 <c:pt idx="1">
-                  <c:v>4.567689404358762</c:v>
+                  <c:v>4.566749988643354</c:v>
                 </c:pt>
                 <c:pt idx="2">
-                  <c:v>4.548308238094193</c:v>
+                  <c:v>4.5445643107574805</c:v>
                 </c:pt>
                 <c:pt idx="3">
-                  <c:v>4.546401322495105</c:v>
+                  <c:v>4.537865580963501</c:v>
                 </c:pt>
                 <c:pt idx="4">
-                  <c:v>4.5186960192690995</c:v>
+                  <c:v>4.521570170405109</c:v>
                 </c:pt>
                 <c:pt idx="5">
-                  <c:v>4.474387468442645</c:v>
+                  <c:v>4.513047560193372</c:v>
                 </c:pt>
                 <c:pt idx="6">
-                  <c:v>4.4234903920678015</c:v>
+                  <c:v>4.447416939450967</c:v>
                 </c:pt>
                 <c:pt idx="7">
-                  <c:v>4.423208073580054</c:v>
+                  <c:v>4.4176247888023905</c:v>
                 </c:pt>
                 <c:pt idx="8">
-                  <c:v>4.418338378937039</c:v>
+                  <c:v>4.415833521022825</c:v>
                 </c:pt>
                 <c:pt idx="9">
-                  <c:v>4.413732039431787</c:v>
+                  <c:v>4.414621038220025</c:v>
                 </c:pt>
               </c:numCache>
             </c:numRef>
@@ -1155,49 +1155,49 @@
               <c:strCache>
                 <c:ptCount val="15"/>
                 <c:pt idx="0">
+                  <c:v>Coimbatore Kalapatti</c:v>
+                </c:pt>
+                <c:pt idx="1">
                   <c:v>Valasaravakkam</c:v>
                 </c:pt>
-                <c:pt idx="1">
+                <c:pt idx="2">
+                  <c:v>Coimbatore Chetty Street</c:v>
+                </c:pt>
+                <c:pt idx="3">
                   <c:v>Salem 2</c:v>
                 </c:pt>
-                <c:pt idx="2">
-                  <c:v>Hosur 3</c:v>
-                </c:pt>
-                <c:pt idx="3">
+                <c:pt idx="4">
+                  <c:v>Coimbatore 4</c:v>
+                </c:pt>
+                <c:pt idx="5">
                   <c:v>Vellore</c:v>
-                </c:pt>
-                <c:pt idx="4">
-                  <c:v>Coimbatore Chetty Street</c:v>
-                </c:pt>
-                <c:pt idx="5">
-                  <c:v>Coimbatore 4</c:v>
                 </c:pt>
                 <c:pt idx="6">
                   <c:v>Salem Yercaud Foothills</c:v>
                 </c:pt>
                 <c:pt idx="7">
+                  <c:v>Hosur 3</c:v>
+                </c:pt>
+                <c:pt idx="8">
                   <c:v>Madurai</c:v>
                 </c:pt>
-                <c:pt idx="8">
-                  <c:v>Coimbatore Kalapatti</c:v>
-                </c:pt>
                 <c:pt idx="9">
-                  <c:v>Padur</c:v>
+                  <c:v>Tiruppur 2</c:v>
                 </c:pt>
                 <c:pt idx="10">
                   <c:v>Coimbatore 6</c:v>
                 </c:pt>
                 <c:pt idx="11">
-                  <c:v>Thoraipakkam</c:v>
+                  <c:v>Coimbatore 2</c:v>
                 </c:pt>
                 <c:pt idx="12">
-                  <c:v>Pollachi</c:v>
+                  <c:v>Palavakkam</c:v>
                 </c:pt>
                 <c:pt idx="13">
-                  <c:v>Moolakadai</c:v>
+                  <c:v>Padur</c:v>
                 </c:pt>
                 <c:pt idx="14">
-                  <c:v>Coimbatore 2</c:v>
+                  <c:v>Thanjavur</c:v>
                 </c:pt>
               </c:strCache>
             </c:strRef>
@@ -1209,49 +1209,49 @@
                 <c:formatCode>General</c:formatCode>
                 <c:ptCount val="15"/>
                 <c:pt idx="0">
-                  <c:v>86.53846153846155</c:v>
+                  <c:v>95.16616314199395</c:v>
                 </c:pt>
                 <c:pt idx="1">
-                  <c:v>86.51315789473685</c:v>
+                  <c:v>94.83870967741936</c:v>
                 </c:pt>
                 <c:pt idx="2">
-                  <c:v>85.76429404900817</c:v>
+                  <c:v>92.619926199262</c:v>
                 </c:pt>
                 <c:pt idx="3">
-                  <c:v>85.18164435946463</c:v>
+                  <c:v>91.74917491749174</c:v>
                 </c:pt>
                 <c:pt idx="4">
-                  <c:v>84.4769403824522</c:v>
+                  <c:v>91.1487758945386</c:v>
                 </c:pt>
                 <c:pt idx="5">
-                  <c:v>83.10344827586206</c:v>
+                  <c:v>90.92682926829269</c:v>
                 </c:pt>
                 <c:pt idx="6">
-                  <c:v>81.84523809523809</c:v>
+                  <c:v>90.8284023668639</c:v>
                 </c:pt>
                 <c:pt idx="7">
-                  <c:v>80.66825775656325</c:v>
+                  <c:v>89.24349881796691</c:v>
                 </c:pt>
                 <c:pt idx="8">
-                  <c:v>80.36649214659685</c:v>
+                  <c:v>88.20960698689956</c:v>
                 </c:pt>
                 <c:pt idx="9">
-                  <c:v>80.0</c:v>
+                  <c:v>88.1578947368421</c:v>
                 </c:pt>
                 <c:pt idx="10">
-                  <c:v>79.22661870503596</c:v>
+                  <c:v>88.09523809523809</c:v>
                 </c:pt>
                 <c:pt idx="11">
-                  <c:v>78.56093979441997</c:v>
+                  <c:v>87.97043010752688</c:v>
                 </c:pt>
                 <c:pt idx="12">
-                  <c:v>78.06451612903226</c:v>
+                  <c:v>86.87050359712231</c:v>
                 </c:pt>
                 <c:pt idx="13">
-                  <c:v>77.55511022044088</c:v>
+                  <c:v>86.46986469864699</c:v>
                 </c:pt>
                 <c:pt idx="14">
-                  <c:v>77.22122838401908</c:v>
+                  <c:v>86.33288227334236</c:v>
                 </c:pt>
               </c:numCache>
             </c:numRef>
@@ -1343,148 +1343,148 @@
                 <c:formatCode>General</c:formatCode>
                 <c:ptCount val="48"/>
                 <c:pt idx="0">
-                  <c:v>4.3149211666799605</c:v>
+                  <c:v>4.31628170289855</c:v>
                 </c:pt>
                 <c:pt idx="1">
-                  <c:v>4.361278489134377</c:v>
+                  <c:v>4.361550240026485</c:v>
                 </c:pt>
                 <c:pt idx="2">
-                  <c:v>4.5343392655822194</c:v>
+                  <c:v>4.533490326545882</c:v>
                 </c:pt>
                 <c:pt idx="3">
-                  <c:v>4.344600909052291</c:v>
+                  <c:v>4.336110762406896</c:v>
                 </c:pt>
                 <c:pt idx="4">
-                  <c:v>4.449302589252755</c:v>
+                  <c:v>4.4467110795753175</c:v>
                 </c:pt>
                 <c:pt idx="5">
-                  <c:v>4.231185481185481</c:v>
+                  <c:v>4.228676809589673</c:v>
                 </c:pt>
                 <c:pt idx="6">
-                  <c:v>4.28173585020923</c:v>
+                  <c:v>4.280527578996967</c:v>
                 </c:pt>
                 <c:pt idx="7">
-                  <c:v>4.3378025194710155</c:v>
+                  <c:v>4.363673383204634</c:v>
                 </c:pt>
                 <c:pt idx="8">
-                  <c:v>4.3964744801512285</c:v>
+                  <c:v>4.390558059452069</c:v>
                 </c:pt>
                 <c:pt idx="9">
-                  <c:v>4.513137706175681</c:v>
+                  <c:v>4.499907201187824</c:v>
                 </c:pt>
                 <c:pt idx="10">
-                  <c:v>4.220191600709312</c:v>
+                  <c:v>4.1913457809834025</c:v>
                 </c:pt>
                 <c:pt idx="11">
-                  <c:v>4.301421441939222</c:v>
+                  <c:v>4.2987556460898055</c:v>
                 </c:pt>
                 <c:pt idx="12">
-                  <c:v>4.225795361247948</c:v>
+                  <c:v>4.206204333585286</c:v>
                 </c:pt>
                 <c:pt idx="13">
-                  <c:v>4.358082880974448</c:v>
+                  <c:v>4.355529173811722</c:v>
                 </c:pt>
                 <c:pt idx="14">
-                  <c:v>4.279690013159819</c:v>
+                  <c:v>4.26937732560878</c:v>
                 </c:pt>
                 <c:pt idx="15">
-                  <c:v>4.195614035087719</c:v>
+                  <c:v>4.189044213263979</c:v>
                 </c:pt>
                 <c:pt idx="16">
-                  <c:v>4.324172576832152</c:v>
+                  <c:v>4.3621610616077415</c:v>
                 </c:pt>
                 <c:pt idx="17">
-                  <c:v>4.325853843410023</c:v>
+                  <c:v>4.28594450880789</c:v>
                 </c:pt>
                 <c:pt idx="18">
-                  <c:v>4.359382366808109</c:v>
+                  <c:v>4.342082885785894</c:v>
                 </c:pt>
                 <c:pt idx="19">
-                  <c:v>4.289209726443769</c:v>
+                  <c:v>4.286168280871671</c:v>
                 </c:pt>
                 <c:pt idx="20">
-                  <c:v>4.219739128392974</c:v>
+                  <c:v>4.212122785160576</c:v>
                 </c:pt>
                 <c:pt idx="21">
-                  <c:v>4.367681225356384</c:v>
+                  <c:v>4.367577417067213</c:v>
                 </c:pt>
                 <c:pt idx="22">
-                  <c:v>4.294391687310762</c:v>
+                  <c:v>4.282138848805515</c:v>
                 </c:pt>
                 <c:pt idx="23">
-                  <c:v>4.253773731714908</c:v>
+                  <c:v>4.349892299407646</c:v>
                 </c:pt>
                 <c:pt idx="24">
-                  <c:v>4.331427845528455</c:v>
+                  <c:v>4.337361878453039</c:v>
                 </c:pt>
                 <c:pt idx="25">
-                  <c:v>4.225856999426276</c:v>
+                  <c:v>4.212115654991137</c:v>
                 </c:pt>
                 <c:pt idx="26">
-                  <c:v>4.294804355850868</c:v>
+                  <c:v>4.285722194103505</c:v>
                 </c:pt>
                 <c:pt idx="27">
-                  <c:v>4.180439725439726</c:v>
+                  <c:v>4.19149299244719</c:v>
                 </c:pt>
                 <c:pt idx="28">
-                  <c:v>4.301171377641966</c:v>
+                  <c:v>4.298823469749987</c:v>
                 </c:pt>
                 <c:pt idx="29">
-                  <c:v>4.412705409619767</c:v>
+                  <c:v>4.409695318805488</c:v>
                 </c:pt>
                 <c:pt idx="30">
-                  <c:v>4.390756718528996</c:v>
+                  <c:v>4.380726354115529</c:v>
                 </c:pt>
                 <c:pt idx="31">
-                  <c:v>4.274594629237966</c:v>
+                  <c:v>4.279732473953735</c:v>
                 </c:pt>
                 <c:pt idx="32">
-                  <c:v>4.2811936228235785</c:v>
+                  <c:v>4.255525265800006</c:v>
                 </c:pt>
                 <c:pt idx="33">
-                  <c:v>4.549302944862156</c:v>
+                  <c:v>4.542820286009141</c:v>
                 </c:pt>
                 <c:pt idx="34">
-                  <c:v>4.383182328978789</c:v>
+                  <c:v>4.3847600397861495</c:v>
                 </c:pt>
                 <c:pt idx="35">
-                  <c:v>4.221984805318139</c:v>
+                  <c:v>4.248050725936547</c:v>
                 </c:pt>
                 <c:pt idx="36">
-                  <c:v>4.373657521616706</c:v>
+                  <c:v>4.373869509043927</c:v>
                 </c:pt>
                 <c:pt idx="37">
-                  <c:v>4.361560302086937</c:v>
+                  <c:v>4.348593328840971</c:v>
                 </c:pt>
                 <c:pt idx="38">
-                  <c:v>4.274744784731469</c:v>
+                  <c:v>4.268092937658156</c:v>
                 </c:pt>
                 <c:pt idx="39">
-                  <c:v>4.292088760250844</c:v>
+                  <c:v>4.298629829290206</c:v>
                 </c:pt>
                 <c:pt idx="40">
-                  <c:v>4.115274983232729</c:v>
+                  <c:v>4.131599654787288</c:v>
                 </c:pt>
                 <c:pt idx="41">
-                  <c:v>4.361571198527721</c:v>
+                  <c:v>4.362844371465061</c:v>
                 </c:pt>
                 <c:pt idx="42">
-                  <c:v>4.336230188952961</c:v>
+                  <c:v>4.334825937950939</c:v>
                 </c:pt>
                 <c:pt idx="43">
-                  <c:v>4.335554430949167</c:v>
+                  <c:v>4.344193951588318</c:v>
                 </c:pt>
                 <c:pt idx="44">
-                  <c:v>4.447115384615384</c:v>
+                  <c:v>4.4526748971193415</c:v>
                 </c:pt>
                 <c:pt idx="45">
-                  <c:v>4.20956670956671</c:v>
+                  <c:v>4.162248455867703</c:v>
                 </c:pt>
                 <c:pt idx="46">
-                  <c:v>4.449965986394558</c:v>
+                  <c:v>4.444255736714975</c:v>
                 </c:pt>
                 <c:pt idx="47">
-                  <c:v>4.262723591974861</c:v>
+                  <c:v>4.267624351720887</c:v>
                 </c:pt>
               </c:numCache>
             </c:numRef>
@@ -1496,148 +1496,148 @@
                 <c:formatCode>General</c:formatCode>
                 <c:ptCount val="48"/>
                 <c:pt idx="0">
-                  <c:v>3.8302083333333337</c:v>
+                  <c:v>3.7797288971041283</c:v>
                 </c:pt>
                 <c:pt idx="1">
-                  <c:v>3.962929835022858</c:v>
+                  <c:v>3.9157036029911625</c:v>
                 </c:pt>
                 <c:pt idx="2">
-                  <c:v>4.21790860826697</c:v>
+                  <c:v>4.185752330226365</c:v>
                 </c:pt>
                 <c:pt idx="3">
-                  <c:v>4.1444193061840116</c:v>
+                  <c:v>4.109080188679245</c:v>
                 </c:pt>
                 <c:pt idx="4">
-                  <c:v>4.443917410714286</c:v>
+                  <c:v>4.431888544891641</c:v>
                 </c:pt>
                 <c:pt idx="5">
-                  <c:v>4.1758345086976965</c:v>
+                  <c:v>4.222756410256411</c:v>
                 </c:pt>
                 <c:pt idx="6">
-                  <c:v>3.9083604777415855</c:v>
+                  <c:v>3.8264771877337322</c:v>
                 </c:pt>
                 <c:pt idx="7">
-                  <c:v>3.925219667227519</c:v>
+                  <c:v>3.9063809967396366</c:v>
                 </c:pt>
                 <c:pt idx="8">
-                  <c:v>4.025611175785797</c:v>
+                  <c:v>3.9012184508268057</c:v>
                 </c:pt>
                 <c:pt idx="9">
-                  <c:v>4.384237421383648</c:v>
+                  <c:v>4.531853281853282</c:v>
                 </c:pt>
                 <c:pt idx="10">
-                  <c:v>3.7928966789667897</c:v>
+                  <c:v>3.700884086444008</c:v>
                 </c:pt>
                 <c:pt idx="11">
-                  <c:v>3.9571398260131554</c:v>
+                  <c:v>3.835003579098067</c:v>
                 </c:pt>
                 <c:pt idx="12">
-                  <c:v>3.702424242424243</c:v>
+                  <c:v>3.87595818815331</c:v>
                 </c:pt>
                 <c:pt idx="13">
-                  <c:v>3.8534401508011307</c:v>
+                  <c:v>3.8294930875576036</c:v>
                 </c:pt>
                 <c:pt idx="14">
-                  <c:v>4.132208157524613</c:v>
+                  <c:v>4.026957637997433</c:v>
                 </c:pt>
                 <c:pt idx="15">
-                  <c:v>4.080309139784946</c:v>
+                  <c:v>3.9888</c:v>
                 </c:pt>
                 <c:pt idx="16">
-                  <c:v>4.243589743589744</c:v>
+                  <c:v>4.315186246418338</c:v>
                 </c:pt>
                 <c:pt idx="17">
-                  <c:v>3.965869218500797</c:v>
+                  <c:v>3.939969604863222</c:v>
                 </c:pt>
                 <c:pt idx="18">
-                  <c:v>4.004742547425474</c:v>
+                  <c:v>4.042959427207637</c:v>
                 </c:pt>
                 <c:pt idx="19">
-                  <c:v>3.9515441959531414</c:v>
+                  <c:v>3.883431952662722</c:v>
                 </c:pt>
                 <c:pt idx="20">
-                  <c:v>4.249242424242424</c:v>
+                  <c:v>4.166103603603603</c:v>
                 </c:pt>
                 <c:pt idx="21">
-                  <c:v>4.056578380706288</c:v>
+                  <c:v>3.9764595103578153</c:v>
                 </c:pt>
                 <c:pt idx="22">
-                  <c:v>3.860989278752437</c:v>
+                  <c:v>3.9575799721835883</c:v>
                 </c:pt>
                 <c:pt idx="23">
-                  <c:v>3.8616557734204795</c:v>
+                  <c:v>4.153919694072658</c:v>
                 </c:pt>
                 <c:pt idx="24">
-                  <c:v>3.903453689167975</c:v>
+                  <c:v>4.101254480286738</c:v>
                 </c:pt>
                 <c:pt idx="25">
-                  <c:v>3.6888990638990635</c:v>
+                  <c:v>3.550956937799043</c:v>
                 </c:pt>
                 <c:pt idx="26">
-                  <c:v>3.6685941601049867</c:v>
+                  <c:v>3.586793396698349</c:v>
                 </c:pt>
                 <c:pt idx="27">
-                  <c:v>3.821373811714198</c:v>
+                  <c:v>3.7300204918032787</c:v>
                 </c:pt>
                 <c:pt idx="28">
-                  <c:v>4.199910394265233</c:v>
+                  <c:v>4.1957908163265305</c:v>
                 </c:pt>
                 <c:pt idx="29">
-                  <c:v>3.8281786941580753</c:v>
+                  <c:v>3.771198830409357</c:v>
                 </c:pt>
                 <c:pt idx="30">
-                  <c:v>3.860551075268817</c:v>
+                  <c:v>3.9676015473887816</c:v>
                 </c:pt>
                 <c:pt idx="31">
-                  <c:v>4.032876712328767</c:v>
+                  <c:v>4.111111111111111</c:v>
                 </c:pt>
                 <c:pt idx="32">
-                  <c:v>4.0428359571070045</c:v>
+                  <c:v>3.95254936634247</c:v>
                 </c:pt>
                 <c:pt idx="33">
-                  <c:v>4.322057205720572</c:v>
+                  <c:v>4.225409836065574</c:v>
                 </c:pt>
                 <c:pt idx="34">
-                  <c:v>4.226013847675569</c:v>
+                  <c:v>4.039184952978056</c:v>
                 </c:pt>
                 <c:pt idx="35">
-                  <c:v>3.752932551319648</c:v>
+                  <c:v>3.7491610738255035</c:v>
                 </c:pt>
                 <c:pt idx="36">
-                  <c:v>3.9448581560283684</c:v>
+                  <c:v>4.0</c:v>
                 </c:pt>
                 <c:pt idx="37">
-                  <c:v>4.168187347931873</c:v>
+                  <c:v>4.153901734104046</c:v>
                 </c:pt>
                 <c:pt idx="38">
-                  <c:v>4.043889648882809</c:v>
+                  <c:v>3.888888888888889</c:v>
                 </c:pt>
                 <c:pt idx="39">
-                  <c:v>3.8818316100443133</c:v>
+                  <c:v>4.184121621621622</c:v>
                 </c:pt>
                 <c:pt idx="40">
-                  <c:v>4.07909604519774</c:v>
+                  <c:v>4.05524861878453</c:v>
                 </c:pt>
                 <c:pt idx="41">
-                  <c:v>3.8260190664036813</c:v>
+                  <c:v>3.6799116997792494</c:v>
                 </c:pt>
                 <c:pt idx="42">
-                  <c:v>4.199395576131687</c:v>
+                  <c:v>4.103992571959146</c:v>
                 </c:pt>
                 <c:pt idx="43">
-                  <c:v>4.121068114958136</c:v>
+                  <c:v>4.107993850883935</c:v>
                 </c:pt>
                 <c:pt idx="44">
-                  <c:v>4.086538461538461</c:v>
+                  <c:v>4.4573170731707314</c:v>
                 </c:pt>
                 <c:pt idx="45">
-                  <c:v>3.875</c:v>
+                  <c:v>3.931862745098039</c:v>
                 </c:pt>
                 <c:pt idx="46">
-                  <c:v>4.419887278582931</c:v>
+                  <c:v>4.397095959595959</c:v>
                 </c:pt>
                 <c:pt idx="47">
-                  <c:v>4.0854810996563575</c:v>
+                  <c:v>3.8482849604221636</c:v>
                 </c:pt>
               </c:numCache>
             </c:numRef>
@@ -1734,95 +1734,113 @@
           </c:spPr>
           <c:cat>
             <c:strRef>
-              <c:f>Sheet1!$A$2:$A$14</c:f>
+              <c:f>Sheet1!$A$2:$A$17</c:f>
               <c:strCache>
-                <c:ptCount val="13"/>
+                <c:ptCount val="16"/>
                 <c:pt idx="0">
-                  <c:v>I Language(à®®à¯à®¤à®²à¯ à®®à¯Šà®´à®¿à®ªà¯à®ªà®¾à®Ÿà®®à¯)</c:v>
+                  <c:v>I Language</c:v>
                 </c:pt>
                 <c:pt idx="1">
-                  <c:v>II Language(à®‡à®°à®£à¯à®Ÿà®¾à®®à¯ à®®à¯Šà®´à®¿à®ªà¯à®ªà®¾à®Ÿà®®à¯)</c:v>
+                  <c:v>II Language</c:v>
                 </c:pt>
                 <c:pt idx="2">
-                  <c:v>III Language(à®®à¯‚à®©à¯à®±à®¾à®®à¯ à®®à¯Šà®´à®¿à®ªà¯à®ªà®¾à®Ÿà®®à¯)</c:v>
+                  <c:v>III Language</c:v>
                 </c:pt>
                 <c:pt idx="3">
-                  <c:v>Mathematics(à®•à®£à®¿à®¤à®®à¯)</c:v>
+                  <c:v>Mathematics</c:v>
                 </c:pt>
                 <c:pt idx="4">
-                  <c:v>General Science(à®ªà¯Šà®¤à¯ à®…à®±à®¿à®µà®¿à®¯à®²à¯)</c:v>
+                  <c:v>General Science</c:v>
                 </c:pt>
                 <c:pt idx="5">
-                  <c:v>Social Studies(à®šà®®à¯‚à®• à®…à®±à®¿à®µà®¿à®¯à®²à¯)</c:v>
+                  <c:v>Social Studies</c:v>
                 </c:pt>
                 <c:pt idx="6">
-                  <c:v>Literacy ( English) Reading/writting/identification</c:v>
+                  <c:v>Subject Wise Feedback</c:v>
                 </c:pt>
                 <c:pt idx="7">
-                  <c:v>Numeracy  (Math)</c:v>
+                  <c:v>Subject Wise Feedback.1</c:v>
                 </c:pt>
                 <c:pt idx="8">
-                  <c:v>General awareness</c:v>
+                  <c:v>Subject Wise Feedback.2</c:v>
                 </c:pt>
                 <c:pt idx="9">
-                  <c:v>Second language(NA for Pre K)</c:v>
+                  <c:v>Subject Wise Feedback.3</c:v>
                 </c:pt>
                 <c:pt idx="10">
-                  <c:v>Physics(à®‡à®¯à®±à¯à®ªà®¿à®¯à®²à¯)</c:v>
+                  <c:v>I Language 2</c:v>
                 </c:pt>
                 <c:pt idx="11">
-                  <c:v>Chemistry(à®µà¯‡à®¤à®¿à®¯à®¿à®¯à®²à¯)</c:v>
+                  <c:v>II Language 2</c:v>
                 </c:pt>
                 <c:pt idx="12">
-                  <c:v>Biology(à®‰à®¯à®¿à®°à®¿à®¯à®²à¯)</c:v>
+                  <c:v>Physics</c:v>
+                </c:pt>
+                <c:pt idx="13">
+                  <c:v>Chemistry</c:v>
+                </c:pt>
+                <c:pt idx="14">
+                  <c:v>Biology</c:v>
+                </c:pt>
+                <c:pt idx="15">
+                  <c:v>Social Studies 2</c:v>
                 </c:pt>
               </c:strCache>
             </c:strRef>
           </c:cat>
           <c:val>
             <c:numRef>
-              <c:f>Sheet1!$B$2:$B$14</c:f>
+              <c:f>Sheet1!$B$2:$B$17</c:f>
               <c:numCache>
                 <c:formatCode>General</c:formatCode>
-                <c:ptCount val="13"/>
+                <c:ptCount val="16"/>
                 <c:pt idx="0">
-                  <c:v>4.398296276211135</c:v>
+                  <c:v>4.418754107938363</c:v>
                 </c:pt>
                 <c:pt idx="1">
-                  <c:v>4.2078433156661585</c:v>
+                  <c:v>4.208500693785146</c:v>
                 </c:pt>
                 <c:pt idx="2">
-                  <c:v>4.010297829379102</c:v>
+                  <c:v>4.00553141050968</c:v>
                 </c:pt>
                 <c:pt idx="3">
-                  <c:v>4.304505649076637</c:v>
+                  <c:v>4.296709150455747</c:v>
                 </c:pt>
                 <c:pt idx="4">
-                  <c:v>4.3994497145907765</c:v>
+                  <c:v>4.398780398743884</c:v>
                 </c:pt>
                 <c:pt idx="5">
-                  <c:v>4.298714664715031</c:v>
+                  <c:v>4.408055210691594</c:v>
                 </c:pt>
                 <c:pt idx="6">
-                  <c:v>4.578134651019147</c:v>
+                  <c:v>4.572360205355904</c:v>
                 </c:pt>
                 <c:pt idx="7">
-                  <c:v>4.5898054349573885</c:v>
+                  <c:v>4.584786053882726</c:v>
                 </c:pt>
                 <c:pt idx="8">
-                  <c:v>4.535575048732944</c:v>
+                  <c:v>4.531004366812227</c:v>
                 </c:pt>
                 <c:pt idx="9">
-                  <c:v>4.250048383975227</c:v>
+                  <c:v>4.238500260371463</c:v>
                 </c:pt>
                 <c:pt idx="10">
-                  <c:v>4.24582607804978</c:v>
+                  <c:v>4.353178822028492</c:v>
                 </c:pt>
                 <c:pt idx="11">
-                  <c:v>4.278128366938587</c:v>
+                  <c:v>4.192881794650561</c:v>
                 </c:pt>
                 <c:pt idx="12">
-                  <c:v>4.337516005121639</c:v>
+                  <c:v>4.236200701329062</c:v>
+                </c:pt>
+                <c:pt idx="13">
+                  <c:v>4.265373432278783</c:v>
+                </c:pt>
+                <c:pt idx="14">
+                  <c:v>4.321253630413109</c:v>
+                </c:pt>
+                <c:pt idx="15">
+                  <c:v>4.142588626131048</c:v>
                 </c:pt>
               </c:numCache>
             </c:numRef>
@@ -1936,16 +1954,16 @@
                 <c:formatCode>General</c:formatCode>
                 <c:ptCount val="4"/>
                 <c:pt idx="0">
-                  <c:v>4.269529711691919</c:v>
+                  <c:v>4.257543961212823</c:v>
                 </c:pt>
                 <c:pt idx="1">
-                  <c:v>4.4125050423557886</c:v>
+                  <c:v>4.402281850834566</c:v>
                 </c:pt>
                 <c:pt idx="2">
-                  <c:v>4.33379405666897</c:v>
+                  <c:v>4.322082449596528</c:v>
                 </c:pt>
                 <c:pt idx="3">
-                  <c:v>4.1839402821415765</c:v>
+                  <c:v>4.171935703632782</c:v>
                 </c:pt>
               </c:numCache>
             </c:numRef>
@@ -2049,10 +2067,10 @@
                 <c:formatCode>General</c:formatCode>
                 <c:ptCount val="2"/>
                 <c:pt idx="0">
-                  <c:v>4.413574467218954</c:v>
+                  <c:v>4.361234024161847</c:v>
                 </c:pt>
                 <c:pt idx="1">
-                  <c:v>0.5864255327810461</c:v>
+                  <c:v>0.6387659758381528</c:v>
                 </c:pt>
               </c:numCache>
             </c:numRef>
@@ -7449,7 +7467,7 @@
           <a:lstStyle/>
           <a:p>
             <a:r>
-              <a:t>• Other - 29.3%</a:t>
+              <a:t>• Other - 55.6%</a:t>
             </a:r>
           </a:p>
         </p:txBody>
@@ -7477,7 +7495,7 @@
           <a:lstStyle/>
           <a:p>
             <a:r>
-              <a:t>• Communication - 18.6%</a:t>
+              <a:t>• Communication - 15.2%</a:t>
             </a:r>
           </a:p>
         </p:txBody>
@@ -7505,7 +7523,7 @@
           <a:lstStyle/>
           <a:p>
             <a:r>
-              <a:t>• Discipline &amp; Values - 13.7%</a:t>
+              <a:t>• Discipline &amp; Values - 8.6%</a:t>
             </a:r>
           </a:p>
         </p:txBody>
@@ -7533,7 +7551,7 @@
           <a:lstStyle/>
           <a:p>
             <a:r>
-              <a:t>• Student Communication - 10.9%</a:t>
+              <a:t>• Student Communication - 7.1%</a:t>
             </a:r>
           </a:p>
         </p:txBody>
@@ -7561,7 +7579,7 @@
           <a:lstStyle/>
           <a:p>
             <a:r>
-              <a:t>• Events &amp; Celebrations - 10.6%</a:t>
+              <a:t>• Events &amp; Celebrations - 6.6%</a:t>
             </a:r>
           </a:p>
         </p:txBody>
@@ -7589,7 +7607,7 @@
           <a:lstStyle/>
           <a:p>
             <a:r>
-              <a:t>• Academics &amp; Activities - 6.1%</a:t>
+              <a:t>• Sports - 3.5%</a:t>
             </a:r>
           </a:p>
         </p:txBody>
@@ -7617,7 +7635,7 @@
           <a:lstStyle/>
           <a:p>
             <a:r>
-              <a:t>• Transport - 4.9%</a:t>
+              <a:t>• Transport - 3.3%</a:t>
             </a:r>
           </a:p>
         </p:txBody>
@@ -7630,8 +7648,8 @@
         </p:nvSpPr>
         <p:spPr>
           <a:xfrm>
-            <a:off x="914400" y="3794760"/>
-            <a:ext cx="3474720" cy="365760"/>
+            <a:off x="4754880" y="1097280"/>
+            <a:ext cx="3840480" cy="457200"/>
           </a:xfrm>
           <a:prstGeom prst="rect">
             <a:avLst/>
@@ -7644,8 +7662,11 @@
           </a:bodyPr>
           <a:lstStyle/>
           <a:p>
-            <a:r>
-              <a:t>• Sports - 4.2%</a:t>
+            <a:pPr>
+              <a:defRPr b="1"/>
+            </a:pPr>
+            <a:r>
+              <a:t>Top Improvements (Why No)</a:t>
             </a:r>
           </a:p>
         </p:txBody>
@@ -7658,8 +7679,8 @@
         </p:nvSpPr>
         <p:spPr>
           <a:xfrm>
-            <a:off x="4754880" y="1097280"/>
-            <a:ext cx="3840480" cy="457200"/>
+            <a:off x="4937760" y="1554480"/>
+            <a:ext cx="3474720" cy="365760"/>
           </a:xfrm>
           <a:prstGeom prst="rect">
             <a:avLst/>
@@ -7672,11 +7693,8 @@
           </a:bodyPr>
           <a:lstStyle/>
           <a:p>
-            <a:pPr>
-              <a:defRPr b="1"/>
-            </a:pPr>
-            <a:r>
-              <a:t>Top Improvements (Why No)</a:t>
+            <a:r>
+              <a:t>• Other - 45.3%</a:t>
             </a:r>
           </a:p>
         </p:txBody>
@@ -7689,7 +7707,7 @@
         </p:nvSpPr>
         <p:spPr>
           <a:xfrm>
-            <a:off x="4937760" y="1554480"/>
+            <a:off x="4937760" y="1874519"/>
             <a:ext cx="3474720" cy="365760"/>
           </a:xfrm>
           <a:prstGeom prst="rect">
@@ -7704,7 +7722,7 @@
           <a:lstStyle/>
           <a:p>
             <a:r>
-              <a:t>• Other - 29.1%</a:t>
+              <a:t>• Communication - 12.7%</a:t>
             </a:r>
           </a:p>
         </p:txBody>
@@ -7717,7 +7735,7 @@
         </p:nvSpPr>
         <p:spPr>
           <a:xfrm>
-            <a:off x="4937760" y="1874519"/>
+            <a:off x="4937760" y="2194560"/>
             <a:ext cx="3474720" cy="365760"/>
           </a:xfrm>
           <a:prstGeom prst="rect">
@@ -7732,7 +7750,7 @@
           <a:lstStyle/>
           <a:p>
             <a:r>
-              <a:t>• Communication - 16.1%</a:t>
+              <a:t>• Sports - 10.9%</a:t>
             </a:r>
           </a:p>
         </p:txBody>
@@ -7745,7 +7763,7 @@
         </p:nvSpPr>
         <p:spPr>
           <a:xfrm>
-            <a:off x="4937760" y="2194560"/>
+            <a:off x="4937760" y="2514600"/>
             <a:ext cx="3474720" cy="365760"/>
           </a:xfrm>
           <a:prstGeom prst="rect">
@@ -7760,7 +7778,7 @@
           <a:lstStyle/>
           <a:p>
             <a:r>
-              <a:t>• Sports - 13.9%</a:t>
+              <a:t>• Student Communication - 10.1%</a:t>
             </a:r>
           </a:p>
         </p:txBody>
@@ -7773,7 +7791,7 @@
         </p:nvSpPr>
         <p:spPr>
           <a:xfrm>
-            <a:off x="4937760" y="2514600"/>
+            <a:off x="4937760" y="2834640"/>
             <a:ext cx="3474720" cy="365760"/>
           </a:xfrm>
           <a:prstGeom prst="rect">
@@ -7788,7 +7806,7 @@
           <a:lstStyle/>
           <a:p>
             <a:r>
-              <a:t>• Discipline &amp; Values - 12.5%</a:t>
+              <a:t>• Discipline &amp; Values - 9.7%</a:t>
             </a:r>
           </a:p>
         </p:txBody>
@@ -7801,7 +7819,7 @@
         </p:nvSpPr>
         <p:spPr>
           <a:xfrm>
-            <a:off x="4937760" y="2834640"/>
+            <a:off x="4937760" y="3154680"/>
             <a:ext cx="3474720" cy="365760"/>
           </a:xfrm>
           <a:prstGeom prst="rect">
@@ -7816,7 +7834,7 @@
           <a:lstStyle/>
           <a:p>
             <a:r>
-              <a:t>• Student Communication - 12.4%</a:t>
+              <a:t>• Events &amp; Celebrations - 6.1%</a:t>
             </a:r>
           </a:p>
         </p:txBody>
@@ -7829,7 +7847,7 @@
         </p:nvSpPr>
         <p:spPr>
           <a:xfrm>
-            <a:off x="4937760" y="3154680"/>
+            <a:off x="4937760" y="3474720"/>
             <a:ext cx="3474720" cy="365760"/>
           </a:xfrm>
           <a:prstGeom prst="rect">
@@ -7844,7 +7862,7 @@
           <a:lstStyle/>
           <a:p>
             <a:r>
-              <a:t>• Events &amp; Celebrations - 8.5%</a:t>
+              <a:t>• Transport - 3.2%</a:t>
             </a:r>
           </a:p>
         </p:txBody>
@@ -7857,7 +7875,7 @@
         </p:nvSpPr>
         <p:spPr>
           <a:xfrm>
-            <a:off x="4937760" y="3474720"/>
+            <a:off x="4937760" y="3794760"/>
             <a:ext cx="3474720" cy="365760"/>
           </a:xfrm>
           <a:prstGeom prst="rect">
@@ -7872,42 +7890,14 @@
           <a:lstStyle/>
           <a:p>
             <a:r>
-              <a:t>• Transport - 4.2%</a:t>
-            </a:r>
-          </a:p>
-        </p:txBody>
-      </p:sp>
-      <p:sp>
-        <p:nvSpPr>
-          <p:cNvPr id="20" name="TextBox 19"/>
-          <p:cNvSpPr txBox="1"/>
-          <p:nvPr/>
-        </p:nvSpPr>
-        <p:spPr>
-          <a:xfrm>
-            <a:off x="4937760" y="3794760"/>
-            <a:ext cx="3474720" cy="365760"/>
-          </a:xfrm>
-          <a:prstGeom prst="rect">
-            <a:avLst/>
-          </a:prstGeom>
-          <a:noFill/>
-        </p:spPr>
-        <p:txBody>
-          <a:bodyPr wrap="none">
-            <a:spAutoFit/>
-          </a:bodyPr>
-          <a:lstStyle/>
-          <a:p>
-            <a:r>
-              <a:t>• No Concerns - 3.3%</a:t>
-            </a:r>
-          </a:p>
-        </p:txBody>
-      </p:sp>
-      <p:sp>
-        <p:nvSpPr>
-          <p:cNvPr id="21" name="Rounded Rectangle 20">
+              <a:t>• No Concerns - 2.0%</a:t>
+            </a:r>
+          </a:p>
+        </p:txBody>
+      </p:sp>
+      <p:sp>
+        <p:nvSpPr>
+          <p:cNvPr id="20" name="Rounded Rectangle 19">
             <a:hlinkClick action="ppaction://hlinksldjump" r:id="rId2"/>
           </p:cNvPr>
           <p:cNvSpPr/>
@@ -7959,7 +7949,7 @@
       </p:sp>
       <p:sp>
         <p:nvSpPr>
-          <p:cNvPr id="22" name="Rounded Rectangle 21">
+          <p:cNvPr id="21" name="Rounded Rectangle 20">
             <a:hlinkClick action="ppaction://hlinksldjump" r:id="rId3"/>
           </p:cNvPr>
           <p:cNvSpPr/>
@@ -8015,7 +8005,7 @@
       </p:sp>
       <p:sp>
         <p:nvSpPr>
-          <p:cNvPr id="23" name="Rounded Rectangle 22">
+          <p:cNvPr id="22" name="Rounded Rectangle 21">
             <a:hlinkClick action="ppaction://hlinksldjump" r:id="rId4"/>
           </p:cNvPr>
           <p:cNvSpPr/>
@@ -8071,7 +8061,7 @@
       </p:sp>
       <p:sp>
         <p:nvSpPr>
-          <p:cNvPr id="24" name="Rounded Rectangle 23">
+          <p:cNvPr id="23" name="Rounded Rectangle 22">
             <a:hlinkClick action="ppaction://hlinksldjump" r:id="rId5"/>
           </p:cNvPr>
           <p:cNvSpPr/>
@@ -8127,7 +8117,7 @@
       </p:sp>
       <p:sp>
         <p:nvSpPr>
-          <p:cNvPr id="25" name="Rounded Rectangle 24">
+          <p:cNvPr id="24" name="Rounded Rectangle 23">
             <a:hlinkClick action="ppaction://hlinksldjump" r:id="rId6"/>
           </p:cNvPr>
           <p:cNvSpPr/>
@@ -8183,7 +8173,7 @@
       </p:sp>
       <p:sp>
         <p:nvSpPr>
-          <p:cNvPr id="26" name="Rounded Rectangle 25">
+          <p:cNvPr id="25" name="Rounded Rectangle 24">
             <a:hlinkClick action="ppaction://hlinksldjump" r:id="rId7"/>
           </p:cNvPr>
           <p:cNvSpPr/>
@@ -8239,7 +8229,7 @@
       </p:sp>
       <p:sp>
         <p:nvSpPr>
-          <p:cNvPr id="27" name="Rounded Rectangle 26">
+          <p:cNvPr id="26" name="Rounded Rectangle 25">
             <a:hlinkClick action="ppaction://hlinksldjump" r:id="rId8"/>
           </p:cNvPr>
           <p:cNvSpPr/>
@@ -8295,7 +8285,7 @@
       </p:sp>
       <p:sp>
         <p:nvSpPr>
-          <p:cNvPr id="28" name="Rounded Rectangle 27">
+          <p:cNvPr id="27" name="Rounded Rectangle 26">
             <a:hlinkClick action="ppaction://hlinksldjump" r:id="rId9"/>
           </p:cNvPr>
           <p:cNvSpPr/>
@@ -8351,7 +8341,7 @@
       </p:sp>
       <p:sp>
         <p:nvSpPr>
-          <p:cNvPr id="29" name="Rounded Rectangle 28">
+          <p:cNvPr id="28" name="Rounded Rectangle 27">
             <a:hlinkClick action="ppaction://hlinksldjump" r:id="rId2"/>
           </p:cNvPr>
           <p:cNvSpPr/>
@@ -9469,7 +9459,7 @@
               </a:defRPr>
             </a:pPr>
             <a:r>
-              <a:t>52541</a:t>
+              <a:t>60255</a:t>
             </a:r>
           </a:p>
         </p:txBody>
@@ -10073,7 +10063,7 @@
           <a:lstStyle/>
           <a:p>
             <a:r>
-              <a:t>• Other 29.3%</a:t>
+              <a:t>• Other 55.6%</a:t>
             </a:r>
           </a:p>
         </p:txBody>
@@ -10101,7 +10091,7 @@
           <a:lstStyle/>
           <a:p>
             <a:r>
-              <a:t>• Communication 18.6%</a:t>
+              <a:t>• Communication 15.2%</a:t>
             </a:r>
           </a:p>
         </p:txBody>
@@ -10129,7 +10119,7 @@
           <a:lstStyle/>
           <a:p>
             <a:r>
-              <a:t>• Discipline &amp; Values 13.7%</a:t>
+              <a:t>• Discipline &amp; Values 8.6%</a:t>
             </a:r>
           </a:p>
         </p:txBody>
@@ -10192,7 +10182,7 @@
           <a:lstStyle/>
           <a:p>
             <a:r>
-              <a:t>• Other 29.1%</a:t>
+              <a:t>• Other 45.3%</a:t>
             </a:r>
           </a:p>
         </p:txBody>
@@ -10220,7 +10210,7 @@
           <a:lstStyle/>
           <a:p>
             <a:r>
-              <a:t>• Communication 16.1%</a:t>
+              <a:t>• Communication 12.7%</a:t>
             </a:r>
           </a:p>
         </p:txBody>
@@ -10248,7 +10238,7 @@
           <a:lstStyle/>
           <a:p>
             <a:r>
-              <a:t>• Sports 13.9%</a:t>
+              <a:t>• Sports 10.9%</a:t>
             </a:r>
           </a:p>
         </p:txBody>
@@ -13898,7 +13888,7 @@
               </a:defRPr>
             </a:pPr>
             <a:r>
-              <a:t>4.47/5.0</a:t>
+              <a:t>4.51/5.0</a:t>
             </a:r>
           </a:p>
         </p:txBody>
@@ -13968,7 +13958,7 @@
               </a:defRPr>
             </a:pPr>
             <a:r>
-              <a:t>4.44/5.0</a:t>
+              <a:t>4.42/5.0</a:t>
             </a:r>
           </a:p>
         </p:txBody>
@@ -14038,7 +14028,7 @@
               </a:defRPr>
             </a:pPr>
             <a:r>
-              <a:t>4.39/5.0</a:t>
+              <a:t>4.28/5.0</a:t>
             </a:r>
           </a:p>
         </p:txBody>
@@ -14108,7 +14098,7 @@
               </a:defRPr>
             </a:pPr>
             <a:r>
-              <a:t>4.33/5.0</a:t>
+              <a:t>4.20/5.0</a:t>
             </a:r>
           </a:p>
         </p:txBody>

</xml_diff>

<commit_message>
Canonicalize subject names and enforce subject ordering
</commit_message>
<xml_diff>
--- a/Pre_Primary_Feedback_Analysis.pptx
+++ b/Pre_Primary_Feedback_Analysis.pptx
@@ -180,7 +180,7 @@
                 <c:formatCode>General</c:formatCode>
                 <c:ptCount val="6"/>
                 <c:pt idx="0">
-                  <c:v>4.31529486798909</c:v>
+                  <c:v>4.344831328745258</c:v>
                 </c:pt>
                 <c:pt idx="1">
                   <c:v>4.321796281853874</c:v>
@@ -861,10 +861,10 @@
                   <c:v>Tiruppur 2</c:v>
                 </c:pt>
                 <c:pt idx="8">
+                  <c:v>Thanjavur</c:v>
+                </c:pt>
+                <c:pt idx="9">
                   <c:v>Salem Yercaud Foothills</c:v>
-                </c:pt>
-                <c:pt idx="9">
-                  <c:v>Thanjavur</c:v>
                 </c:pt>
               </c:strCache>
             </c:strRef>
@@ -876,34 +876,34 @@
                 <c:formatCode>General</c:formatCode>
                 <c:ptCount val="10"/>
                 <c:pt idx="0">
-                  <c:v>4.5788796890073105</c:v>
+                  <c:v>4.5816219611908044</c:v>
                 </c:pt>
                 <c:pt idx="1">
-                  <c:v>4.566749988643354</c:v>
+                  <c:v>4.5733366803908035</c:v>
                 </c:pt>
                 <c:pt idx="2">
-                  <c:v>4.5445643107574805</c:v>
+                  <c:v>4.551341388976032</c:v>
                 </c:pt>
                 <c:pt idx="3">
-                  <c:v>4.537865580963501</c:v>
+                  <c:v>4.541062184036039</c:v>
                 </c:pt>
                 <c:pt idx="4">
-                  <c:v>4.521570170405109</c:v>
+                  <c:v>4.523916727695391</c:v>
                 </c:pt>
                 <c:pt idx="5">
-                  <c:v>4.513047560193372</c:v>
+                  <c:v>4.518719665744437</c:v>
                 </c:pt>
                 <c:pt idx="6">
-                  <c:v>4.447416939450967</c:v>
+                  <c:v>4.453909714120124</c:v>
                 </c:pt>
                 <c:pt idx="7">
-                  <c:v>4.4176247888023905</c:v>
+                  <c:v>4.424086608361298</c:v>
                 </c:pt>
                 <c:pt idx="8">
-                  <c:v>4.415833521022825</c:v>
+                  <c:v>4.421455252270692</c:v>
                 </c:pt>
                 <c:pt idx="9">
-                  <c:v>4.414621038220025</c:v>
+                  <c:v>4.419715269690246</c:v>
                 </c:pt>
               </c:numCache>
             </c:numRef>
@@ -1020,10 +1020,10 @@
                   <c:v>Tiruppur 2</c:v>
                 </c:pt>
                 <c:pt idx="8">
+                  <c:v>Thanjavur</c:v>
+                </c:pt>
+                <c:pt idx="9">
                   <c:v>Salem Yercaud Foothills</c:v>
-                </c:pt>
-                <c:pt idx="9">
-                  <c:v>Thanjavur</c:v>
                 </c:pt>
               </c:strCache>
             </c:strRef>
@@ -1035,34 +1035,34 @@
                 <c:formatCode>General</c:formatCode>
                 <c:ptCount val="10"/>
                 <c:pt idx="0">
-                  <c:v>4.5788796890073105</c:v>
+                  <c:v>4.5816219611908044</c:v>
                 </c:pt>
                 <c:pt idx="1">
-                  <c:v>4.566749988643354</c:v>
+                  <c:v>4.5733366803908035</c:v>
                 </c:pt>
                 <c:pt idx="2">
-                  <c:v>4.5445643107574805</c:v>
+                  <c:v>4.551341388976032</c:v>
                 </c:pt>
                 <c:pt idx="3">
-                  <c:v>4.537865580963501</c:v>
+                  <c:v>4.541062184036039</c:v>
                 </c:pt>
                 <c:pt idx="4">
-                  <c:v>4.521570170405109</c:v>
+                  <c:v>4.523916727695391</c:v>
                 </c:pt>
                 <c:pt idx="5">
-                  <c:v>4.513047560193372</c:v>
+                  <c:v>4.518719665744437</c:v>
                 </c:pt>
                 <c:pt idx="6">
-                  <c:v>4.447416939450967</c:v>
+                  <c:v>4.453909714120124</c:v>
                 </c:pt>
                 <c:pt idx="7">
-                  <c:v>4.4176247888023905</c:v>
+                  <c:v>4.424086608361298</c:v>
                 </c:pt>
                 <c:pt idx="8">
-                  <c:v>4.415833521022825</c:v>
+                  <c:v>4.421455252270692</c:v>
                 </c:pt>
                 <c:pt idx="9">
-                  <c:v>4.414621038220025</c:v>
+                  <c:v>4.419715269690246</c:v>
                 </c:pt>
               </c:numCache>
             </c:numRef>
@@ -1343,148 +1343,148 @@
                 <c:formatCode>General</c:formatCode>
                 <c:ptCount val="48"/>
                 <c:pt idx="0">
-                  <c:v>4.31628170289855</c:v>
+                  <c:v>4.341105756774962</c:v>
                 </c:pt>
                 <c:pt idx="1">
-                  <c:v>4.361550240026485</c:v>
+                  <c:v>4.387059351276742</c:v>
                 </c:pt>
                 <c:pt idx="2">
-                  <c:v>4.533490326545882</c:v>
+                  <c:v>4.5714572978461865</c:v>
                 </c:pt>
                 <c:pt idx="3">
-                  <c:v>4.336110762406896</c:v>
+                  <c:v>4.3593876952716</c:v>
                 </c:pt>
                 <c:pt idx="4">
-                  <c:v>4.4467110795753175</c:v>
+                  <c:v>4.472703235990529</c:v>
                 </c:pt>
                 <c:pt idx="5">
-                  <c:v>4.228676809589673</c:v>
+                  <c:v>4.25160598865585</c:v>
                 </c:pt>
                 <c:pt idx="6">
-                  <c:v>4.280527578996967</c:v>
+                  <c:v>4.301802657944366</c:v>
                 </c:pt>
                 <c:pt idx="7">
-                  <c:v>4.363673383204634</c:v>
+                  <c:v>4.394211787930063</c:v>
                 </c:pt>
                 <c:pt idx="8">
-                  <c:v>4.390558059452069</c:v>
+                  <c:v>4.410196485542108</c:v>
                 </c:pt>
                 <c:pt idx="9">
-                  <c:v>4.499907201187824</c:v>
+                  <c:v>4.5165738678544916</c:v>
                 </c:pt>
                 <c:pt idx="10">
-                  <c:v>4.1913457809834025</c:v>
+                  <c:v>4.218525089188771</c:v>
                 </c:pt>
                 <c:pt idx="11">
-                  <c:v>4.2987556460898055</c:v>
+                  <c:v>4.329045995335518</c:v>
                 </c:pt>
                 <c:pt idx="12">
-                  <c:v>4.206204333585286</c:v>
+                  <c:v>4.265263430475071</c:v>
                 </c:pt>
                 <c:pt idx="13">
-                  <c:v>4.355529173811722</c:v>
+                  <c:v>4.3786638500132025</c:v>
                 </c:pt>
                 <c:pt idx="14">
-                  <c:v>4.26937732560878</c:v>
+                  <c:v>4.290990768216289</c:v>
                 </c:pt>
                 <c:pt idx="15">
-                  <c:v>4.189044213263979</c:v>
+                  <c:v>4.224392361111111</c:v>
                 </c:pt>
                 <c:pt idx="16">
-                  <c:v>4.3621610616077415</c:v>
+                  <c:v>4.390399540097729</c:v>
                 </c:pt>
                 <c:pt idx="17">
-                  <c:v>4.28594450880789</c:v>
+                  <c:v>4.324010542303226</c:v>
                 </c:pt>
                 <c:pt idx="18">
-                  <c:v>4.342082885785894</c:v>
+                  <c:v>4.368150286430362</c:v>
                 </c:pt>
                 <c:pt idx="19">
-                  <c:v>4.286168280871671</c:v>
+                  <c:v>4.329104872881356</c:v>
                 </c:pt>
                 <c:pt idx="20">
-                  <c:v>4.212122785160576</c:v>
+                  <c:v>4.2466055810079135</c:v>
                 </c:pt>
                 <c:pt idx="21">
-                  <c:v>4.367577417067213</c:v>
+                  <c:v>4.395267643737031</c:v>
                 </c:pt>
                 <c:pt idx="22">
-                  <c:v>4.282138848805515</c:v>
+                  <c:v>4.312803638309256</c:v>
                 </c:pt>
                 <c:pt idx="23">
-                  <c:v>4.349892299407646</c:v>
+                  <c:v>4.374424955765828</c:v>
                 </c:pt>
                 <c:pt idx="24">
-                  <c:v>4.337361878453039</c:v>
+                  <c:v>4.365216390423573</c:v>
                 </c:pt>
                 <c:pt idx="25">
-                  <c:v>4.212115654991137</c:v>
+                  <c:v>4.238424822218147</c:v>
                 </c:pt>
                 <c:pt idx="26">
-                  <c:v>4.285722194103505</c:v>
+                  <c:v>4.322555780505294</c:v>
                 </c:pt>
                 <c:pt idx="27">
-                  <c:v>4.19149299244719</c:v>
+                  <c:v>4.2333565769261865</c:v>
                 </c:pt>
                 <c:pt idx="28">
-                  <c:v>4.298823469749987</c:v>
+                  <c:v>4.3236878137836605</c:v>
                 </c:pt>
                 <c:pt idx="29">
-                  <c:v>4.409695318805488</c:v>
+                  <c:v>4.433336229869076</c:v>
                 </c:pt>
                 <c:pt idx="30">
-                  <c:v>4.380726354115529</c:v>
+                  <c:v>4.399915112092947</c:v>
                 </c:pt>
                 <c:pt idx="31">
-                  <c:v>4.279732473953735</c:v>
+                  <c:v>4.318220613338042</c:v>
                 </c:pt>
                 <c:pt idx="32">
-                  <c:v>4.255525265800006</c:v>
+                  <c:v>4.292387171286425</c:v>
                 </c:pt>
                 <c:pt idx="33">
-                  <c:v>4.542820286009141</c:v>
+                  <c:v>4.556678460858028</c:v>
                 </c:pt>
                 <c:pt idx="34">
-                  <c:v>4.3847600397861495</c:v>
+                  <c:v>4.403872932985204</c:v>
                 </c:pt>
                 <c:pt idx="35">
-                  <c:v>4.248050725936547</c:v>
+                  <c:v>4.27921233902366</c:v>
                 </c:pt>
                 <c:pt idx="36">
-                  <c:v>4.373869509043927</c:v>
+                  <c:v>4.3993189852360155</c:v>
                 </c:pt>
                 <c:pt idx="37">
-                  <c:v>4.348593328840971</c:v>
+                  <c:v>4.378570024707997</c:v>
                 </c:pt>
                 <c:pt idx="38">
-                  <c:v>4.268092937658156</c:v>
+                  <c:v>4.279148245371649</c:v>
                 </c:pt>
                 <c:pt idx="39">
-                  <c:v>4.298629829290206</c:v>
+                  <c:v>4.355592991913746</c:v>
                 </c:pt>
                 <c:pt idx="40">
-                  <c:v>4.131599654787288</c:v>
+                  <c:v>4.1659849409849405</c:v>
                 </c:pt>
                 <c:pt idx="41">
-                  <c:v>4.362844371465061</c:v>
+                  <c:v>4.378225585536228</c:v>
                 </c:pt>
                 <c:pt idx="42">
-                  <c:v>4.334825937950939</c:v>
+                  <c:v>4.357911255411255</c:v>
                 </c:pt>
                 <c:pt idx="43">
-                  <c:v>4.344193951588318</c:v>
+                  <c:v>4.35934851533443</c:v>
                 </c:pt>
                 <c:pt idx="44">
-                  <c:v>4.4526748971193415</c:v>
+                  <c:v>4.470370370370371</c:v>
                 </c:pt>
                 <c:pt idx="45">
-                  <c:v>4.162248455867703</c:v>
+                  <c:v>4.211474036850921</c:v>
                 </c:pt>
                 <c:pt idx="46">
-                  <c:v>4.444255736714975</c:v>
+                  <c:v>4.472412008281574</c:v>
                 </c:pt>
                 <c:pt idx="47">
-                  <c:v>4.267624351720887</c:v>
+                  <c:v>4.2904349363507785</c:v>
                 </c:pt>
               </c:numCache>
             </c:numRef>
@@ -1734,9 +1734,9 @@
           </c:spPr>
           <c:cat>
             <c:strRef>
-              <c:f>Sheet1!$A$2:$A$17</c:f>
+              <c:f>Sheet1!$A$2:$A$14</c:f>
               <c:strCache>
-                <c:ptCount val="16"/>
+                <c:ptCount val="13"/>
                 <c:pt idx="0">
                   <c:v>I Language</c:v>
                 </c:pt>
@@ -1756,52 +1756,43 @@
                   <c:v>Social Studies</c:v>
                 </c:pt>
                 <c:pt idx="6">
-                  <c:v>Subject Wise Feedback</c:v>
+                  <c:v>Literacy skills( English)</c:v>
                 </c:pt>
                 <c:pt idx="7">
-                  <c:v>Subject Wise Feedback.1</c:v>
+                  <c:v>Numeracy Skills (Math)</c:v>
                 </c:pt>
                 <c:pt idx="8">
-                  <c:v>Subject Wise Feedback.2</c:v>
+                  <c:v>General Awareness</c:v>
                 </c:pt>
                 <c:pt idx="9">
-                  <c:v>Subject Wise Feedback.3</c:v>
+                  <c:v>Second Language (NA for Pre-K)</c:v>
                 </c:pt>
                 <c:pt idx="10">
-                  <c:v>I Language 2</c:v>
+                  <c:v>Physics</c:v>
                 </c:pt>
                 <c:pt idx="11">
-                  <c:v>II Language 2</c:v>
+                  <c:v>Chemistry</c:v>
                 </c:pt>
                 <c:pt idx="12">
-                  <c:v>Physics</c:v>
-                </c:pt>
-                <c:pt idx="13">
-                  <c:v>Chemistry</c:v>
-                </c:pt>
-                <c:pt idx="14">
                   <c:v>Biology</c:v>
-                </c:pt>
-                <c:pt idx="15">
-                  <c:v>Social Studies 2</c:v>
                 </c:pt>
               </c:strCache>
             </c:strRef>
           </c:cat>
           <c:val>
             <c:numRef>
-              <c:f>Sheet1!$B$2:$B$17</c:f>
+              <c:f>Sheet1!$B$2:$B$14</c:f>
               <c:numCache>
                 <c:formatCode>General</c:formatCode>
-                <c:ptCount val="16"/>
+                <c:ptCount val="13"/>
                 <c:pt idx="0">
-                  <c:v>4.418754107938363</c:v>
+                  <c:v>4.388459951670891</c:v>
                 </c:pt>
                 <c:pt idx="1">
-                  <c:v>4.208500693785146</c:v>
+                  <c:v>4.201340821896136</c:v>
                 </c:pt>
                 <c:pt idx="2">
-                  <c:v>4.00553141050968</c:v>
+                  <c:v>4.020375457875458</c:v>
                 </c:pt>
                 <c:pt idx="3">
                   <c:v>4.296709150455747</c:v>
@@ -1810,7 +1801,7 @@
                   <c:v>4.398780398743884</c:v>
                 </c:pt>
                 <c:pt idx="5">
-                  <c:v>4.408055210691594</c:v>
+                  <c:v>4.28722917454191</c:v>
                 </c:pt>
                 <c:pt idx="6">
                   <c:v>4.572360205355904</c:v>
@@ -1825,22 +1816,13 @@
                   <c:v>4.238500260371463</c:v>
                 </c:pt>
                 <c:pt idx="10">
-                  <c:v>4.353178822028492</c:v>
+                  <c:v>4.236200701329062</c:v>
                 </c:pt>
                 <c:pt idx="11">
-                  <c:v>4.192881794650561</c:v>
+                  <c:v>4.265373432278783</c:v>
                 </c:pt>
                 <c:pt idx="12">
-                  <c:v>4.236200701329062</c:v>
-                </c:pt>
-                <c:pt idx="13">
-                  <c:v>4.265373432278783</c:v>
-                </c:pt>
-                <c:pt idx="14">
                   <c:v>4.321253630413109</c:v>
-                </c:pt>
-                <c:pt idx="15">
-                  <c:v>4.142588626131048</c:v>
                 </c:pt>
               </c:numCache>
             </c:numRef>

</xml_diff>